<commit_message>
Rewrite speaker notes as word-budgeted delivery scripts
</commit_message>
<xml_diff>
--- a/Final_Presentation_Karimi_Lobo.pptx
+++ b/Final_Presentation_Karimi_Lobo.pptx
@@ -512,7 +512,34 @@
           <a:lstStyle/>
           <a:p>
             <a:r>
-              <a:t>[10s]  BORNA. 'We measure how late Bay Area transit actually is — by deriving arrival times that no agency publishes.' Move fast, the next slide is the hook.</a:t>
+              <a:t>[10s  |  BORNA  |  ~21 words @ 126 wpm]</a:t>
+            </a:r>
+          </a:p>
+          <a:p>
+            <a:r>
+              <a:t>==============================================================</a:t>
+            </a:r>
+          </a:p>
+          <a:p/>
+          <a:p>
+            <a:r>
+              <a:t>We measure how late Bay Area transit actually is. The catch: no agency</a:t>
+            </a:r>
+          </a:p>
+          <a:p>
+            <a:r>
+              <a:t>publishes that number. We had to derive it.</a:t>
+            </a:r>
+          </a:p>
+          <a:p/>
+          <a:p>
+            <a:r>
+              <a:t>--------------------------------------------------------------</a:t>
+            </a:r>
+          </a:p>
+          <a:p>
+            <a:r>
+              <a:t>DELIVERY: Do not linger. The hook is the next slide.</a:t>
             </a:r>
           </a:p>
         </p:txBody>
@@ -582,7 +609,39 @@
           <a:lstStyle/>
           <a:p>
             <a:r>
-              <a:t>[12s]  EITHER. Close on reproducibility, then stop talking. Leave the full minute for Q&amp;A.</a:t>
+              <a:t>[12s  |  EITHER  |  ~33 words @ 165 wpm]</a:t>
+            </a:r>
+          </a:p>
+          <a:p>
+            <a:r>
+              <a:t>==============================================================</a:t>
+            </a:r>
+          </a:p>
+          <a:p/>
+          <a:p>
+            <a:r>
+              <a:t>Everything you have seen runs from one command, with no API key, in under two</a:t>
+            </a:r>
+          </a:p>
+          <a:p>
+            <a:r>
+              <a:t>minutes -- eighty-three tests and six acceptance checks, verified from a clean</a:t>
+            </a:r>
+          </a:p>
+          <a:p>
+            <a:r>
+              <a:t>extract of the submitted zip. Questions?</a:t>
+            </a:r>
+          </a:p>
+          <a:p/>
+          <a:p>
+            <a:r>
+              <a:t>--------------------------------------------------------------</a:t>
+            </a:r>
+          </a:p>
+          <a:p>
+            <a:r>
+              <a:t>DELIVERY: Stop talking. Leave the full minute for Q&amp;A.</a:t>
             </a:r>
           </a:p>
         </p:txBody>
@@ -652,7 +711,92 @@
           <a:lstStyle/>
           <a:p>
             <a:r>
-              <a:t>[0s]  APPENDIX -- not presented. Use if asked about the AI element.</a:t>
+              <a:t>[0s  |  APPENDIX  |  ~143 words @ 0 wpm]</a:t>
+            </a:r>
+          </a:p>
+          <a:p>
+            <a:r>
+              <a:t>==============================================================</a:t>
+            </a:r>
+          </a:p>
+          <a:p/>
+          <a:p>
+            <a:r>
+              <a:t>Not presented. Backup for Q&amp;A on the AI element.</a:t>
+            </a:r>
+          </a:p>
+          <a:p/>
+          <a:p>
+            <a:r>
+              <a:t>We predict the residual -- actual arrival minus predicted arrival -- and apply it</a:t>
+            </a:r>
+          </a:p>
+          <a:p>
+            <a:r>
+              <a:t>as a correction on top of the agency's ETA. Predicting zero is identical to</a:t>
+            </a:r>
+          </a:p>
+          <a:p>
+            <a:r>
+              <a:t>trusting the agency, so the baseline comparison is exact.</a:t>
+            </a:r>
+          </a:p>
+          <a:p/>
+          <a:p>
+            <a:r>
+              <a:t>The interesting result is that both naive bias corrections are WORSE than doing</a:t>
+            </a:r>
+          </a:p>
+          <a:p>
+            <a:r>
+              <a:t>nothing. Residuals are heavily right-skewed -- mean plus 213 seconds, median plus</a:t>
+            </a:r>
+          </a:p>
+          <a:p>
+            <a:r>
+              <a:t>111 -- so adding the mean overcorrects the typical case. The model earns its</a:t>
+            </a:r>
+          </a:p>
+          <a:p>
+            <a:r>
+              <a:t>fourteen-point-seven percent by learning a horizon, hour and route dependent</a:t>
+            </a:r>
+          </a:p>
+          <a:p>
+            <a:r>
+              <a:t>correction instead of a constant.</a:t>
+            </a:r>
+          </a:p>
+          <a:p/>
+          <a:p>
+            <a:r>
+              <a:t>On leakage: labels come from GPS positions, features from predictions. Different</a:t>
+            </a:r>
+          </a:p>
+          <a:p>
+            <a:r>
+              <a:t>feeds, so the label cannot contain the feature. We also excluded lead-time as a</a:t>
+            </a:r>
+          </a:p>
+          <a:p>
+            <a:r>
+              <a:t>feature because it contains the target, and we split the data strictly forward in</a:t>
+            </a:r>
+          </a:p>
+          <a:p>
+            <a:r>
+              <a:t>time rather than randomly.</a:t>
+            </a:r>
+          </a:p>
+          <a:p/>
+          <a:p>
+            <a:r>
+              <a:t>--------------------------------------------------------------</a:t>
+            </a:r>
+          </a:p>
+          <a:p>
+            <a:r>
+              <a:t>DELIVERY: Only if asked.</a:t>
             </a:r>
           </a:p>
         </p:txBody>
@@ -722,7 +866,76 @@
           <a:lstStyle/>
           <a:p>
             <a:r>
-              <a:t>[50s]  BORNA. The core surprise. Two feeds, neither states an arrival. Emphasise the last line: scheduled is exact, so derivation error goes directly into the delay number and nothing downstream can fix it.</a:t>
+              <a:t>[50s  |  BORNA  |  ~119 words @ 143 wpm]</a:t>
+            </a:r>
+          </a:p>
+          <a:p>
+            <a:r>
+              <a:t>==============================================================</a:t>
+            </a:r>
+          </a:p>
+          <a:p/>
+          <a:p>
+            <a:r>
+              <a:t>Transit agencies publish two live feeds. TripUpdates is predictions -- the</a:t>
+            </a:r>
+          </a:p>
+          <a:p>
+            <a:r>
+              <a:t>agency telling us a bus will reach stop 22 at 15:07. VehiclePositions is GPS --</a:t>
+            </a:r>
+          </a:p>
+          <a:p>
+            <a:r>
+              <a:t>bus 4821 is at this coordinate, right now.</a:t>
+            </a:r>
+          </a:p>
+          <a:p/>
+          <a:p>
+            <a:r>
+              <a:t>Notice what is missing. Neither feed ever says the bus ARRIVED. That fact is not</a:t>
+            </a:r>
+          </a:p>
+          <a:p>
+            <a:r>
+              <a:t>published by anyone. It has to be derived from indirect evidence.</a:t>
+            </a:r>
+          </a:p>
+          <a:p/>
+          <a:p>
+            <a:r>
+              <a:t>Here is why that is the whole problem. Delay equals actual minus scheduled. The</a:t>
+            </a:r>
+          </a:p>
+          <a:p>
+            <a:r>
+              <a:t>scheduled time is published and exact -- there is no error in it. So every bit of</a:t>
+            </a:r>
+          </a:p>
+          <a:p>
+            <a:r>
+              <a:t>error in our derived actual transfers one-for-one into the delay figure. And</a:t>
+            </a:r>
+          </a:p>
+          <a:p>
+            <a:r>
+              <a:t>nothing downstream can detect or correct it, because there is no ground truth to</a:t>
+            </a:r>
+          </a:p>
+          <a:p>
+            <a:r>
+              <a:t>check against.</a:t>
+            </a:r>
+          </a:p>
+          <a:p/>
+          <a:p>
+            <a:r>
+              <a:t>--------------------------------------------------------------</a:t>
+            </a:r>
+          </a:p>
+          <a:p>
+            <a:r>
+              <a:t>DELIVERY: Slow down on the last sentence. It justifies everything that follows.</a:t>
             </a:r>
           </a:p>
         </p:txBody>
@@ -792,7 +1005,83 @@
           <a:lstStyle/>
           <a:p>
             <a:r>
-              <a:t>[58s]  BORNA. Rubric slide — one representative record. Point at arrival_uncertainty: null. Say the key is service_date:trip_id because trip IDs repeat daily. Then hand to the next slide as the punchline.</a:t>
+              <a:t>[58s  |  BORNA  |  ~148 words @ 153 wpm]</a:t>
+            </a:r>
+          </a:p>
+          <a:p>
+            <a:r>
+              <a:t>==============================================================</a:t>
+            </a:r>
+          </a:p>
+          <a:p/>
+          <a:p>
+            <a:r>
+              <a:t>Our source is 511.org, run by the Metropolitan Transportation Commission. One</a:t>
+            </a:r>
+          </a:p>
+          <a:p>
+            <a:r>
+              <a:t>consolidated feed covers all 28 Bay Area operators, which matters because our</a:t>
+            </a:r>
+          </a:p>
+          <a:p>
+            <a:r>
+              <a:t>quota is 60 requests an hour -- so we can only afford one poll every two minutes.</a:t>
+            </a:r>
+          </a:p>
+          <a:p/>
+          <a:p>
+            <a:r>
+              <a:t>On the left is one real event as it enters Kafka: a single stop on a single trip.</a:t>
+            </a:r>
+          </a:p>
+          <a:p/>
+          <a:p>
+            <a:r>
+              <a:t>Three things to notice. The Kafka key is service_date plus trip_id. We include</a:t>
+            </a:r>
+          </a:p>
+          <a:p>
+            <a:r>
+              <a:t>the date because trip IDs repeat every single day. And we key on the trip so that</a:t>
+            </a:r>
+          </a:p>
+          <a:p>
+            <a:r>
+              <a:t>every observation of one trip lands in the same partition, in order -- that</a:t>
+            </a:r>
+          </a:p>
+          <a:p>
+            <a:r>
+              <a:t>ordering turns out to be load-bearing, and Aatish will show you why.</a:t>
+            </a:r>
+          </a:p>
+          <a:p/>
+          <a:p>
+            <a:r>
+              <a:t>The grain is service date, trip, and stop SEQUENCE -- never stop ID, because seven</a:t>
+            </a:r>
+          </a:p>
+          <a:p>
+            <a:r>
+              <a:t>operators run loops that visit the same stop twice in one trip.</a:t>
+            </a:r>
+          </a:p>
+          <a:p/>
+          <a:p>
+            <a:r>
+              <a:t>And arrival_uncertainty is null. Not zero. Null.</a:t>
+            </a:r>
+          </a:p>
+          <a:p/>
+          <a:p>
+            <a:r>
+              <a:t>--------------------------------------------------------------</a:t>
+            </a:r>
+          </a:p>
+          <a:p>
+            <a:r>
+              <a:t>DELIVERY: Point at the null on the last line and pause -- it sets up the next slide.</a:t>
             </a:r>
           </a:p>
         </p:txBody>
@@ -862,7 +1151,66 @@
           <a:lstStyle/>
           <a:p>
             <a:r>
-              <a:t>[38s]  BORNA. The single best slide in the deck. A fabricated on-time spike that looks completely plausible. Then: 'Aatish will show how that data becomes an answer.' HANDOFF.</a:t>
+              <a:t>[38s  |  BORNA  |  ~103 words @ 163 wpm]</a:t>
+            </a:r>
+          </a:p>
+          <a:p>
+            <a:r>
+              <a:t>==============================================================</a:t>
+            </a:r>
+          </a:p>
+          <a:p/>
+          <a:p>
+            <a:r>
+              <a:t>GTFS-Realtime uses protobuf version 2, where a field can be genuinely absent --</a:t>
+            </a:r>
+          </a:p>
+          <a:p>
+            <a:r>
+              <a:t>and absent is different from zero. A delay of zero means the bus is exactly on</a:t>
+            </a:r>
+          </a:p>
+          <a:p>
+            <a:r>
+              <a:t>time. Absent means the agency told us nothing at all.</a:t>
+            </a:r>
+          </a:p>
+          <a:p/>
+          <a:p>
+            <a:r>
+              <a:t>The trap is that the obvious way to read that field returns zero for both.</a:t>
+            </a:r>
+          </a:p>
+          <a:p/>
+          <a:p>
+            <a:r>
+              <a:t>We measured it. Forty-four percent of records carry no delay at all; nineteen of</a:t>
+            </a:r>
+          </a:p>
+          <a:p>
+            <a:r>
+              <a:t>28 operators never populate it. Written the natural way, we would have reported</a:t>
+            </a:r>
+          </a:p>
+          <a:p>
+            <a:r>
+              <a:t>all fifty-four thousand as perfectly on time -- a fabricated on-time spike that</a:t>
+            </a:r>
+          </a:p>
+          <a:p>
+            <a:r>
+              <a:t>looks entirely plausible and corrupts every number above it.</a:t>
+            </a:r>
+          </a:p>
+          <a:p/>
+          <a:p>
+            <a:r>
+              <a:t>--------------------------------------------------------------</a:t>
+            </a:r>
+          </a:p>
+          <a:p>
+            <a:r>
+              <a:t>DELIVERY: This is the strongest slide in the first half. Pause after 'perfectly on time'.</a:t>
             </a:r>
           </a:p>
         </p:txBody>
@@ -932,7 +1280,98 @@
           <a:lstStyle/>
           <a:p>
             <a:r>
-              <a:t>[62s]  BORNA. Rubric slide. Trace the path left to right in ONE sentence, then give the WHY: one code path for live and replay, and Kafka is transport not storage. Do not read every box. Then hand over: 'Aatish will show this running on a single vehicle.'</a:t>
+              <a:t>[62s  |  BORNA  |  ~160 words @ 155 wpm]</a:t>
+            </a:r>
+          </a:p>
+          <a:p>
+            <a:r>
+              <a:t>==============================================================</a:t>
+            </a:r>
+          </a:p>
+          <a:p/>
+          <a:p>
+            <a:r>
+              <a:t>Here is the implemented path. The poller pulls protobuf every two minutes and</a:t>
+            </a:r>
+          </a:p>
+          <a:p>
+            <a:r>
+              <a:t>writes the raw bytes to disk BEFORE attempting to decode them. A producer then</a:t>
+            </a:r>
+          </a:p>
+          <a:p>
+            <a:r>
+              <a:t>reads from disk, validates every record against our contract, and publishes to</a:t>
+            </a:r>
+          </a:p>
+          <a:p>
+            <a:r>
+              <a:t>Kafka. A resolver derives arrivals, an aggregator joins them back against the</a:t>
+            </a:r>
+          </a:p>
+          <a:p>
+            <a:r>
+              <a:t>predictions, and that produces our metrics.</a:t>
+            </a:r>
+          </a:p>
+          <a:p/>
+          <a:p>
+            <a:r>
+              <a:t>Two design choices worth explaining.</a:t>
+            </a:r>
+          </a:p>
+          <a:p/>
+          <a:p>
+            <a:r>
+              <a:t>First: the poller only ever writes to disk, and everything downstream only ever</a:t>
+            </a:r>
+          </a:p>
+          <a:p>
+            <a:r>
+              <a:t>reads from disk. So live operation and replay are literally the same code path --</a:t>
+            </a:r>
+          </a:p>
+          <a:p>
+            <a:r>
+              <a:t>they differ only in whether new files keep appearing. When you run our demo you</a:t>
+            </a:r>
+          </a:p>
+          <a:p>
+            <a:r>
+              <a:t>are running the real pipeline, not a mock of it.</a:t>
+            </a:r>
+          </a:p>
+          <a:p/>
+          <a:p>
+            <a:r>
+              <a:t>Second: Kafka is transport, not storage. Our topics expire after 24 hours on</a:t>
+            </a:r>
+          </a:p>
+          <a:p>
+            <a:r>
+              <a:t>purpose. GTFS-Realtime has no history endpoint, so anything we fail to archive is</a:t>
+            </a:r>
+          </a:p>
+          <a:p>
+            <a:r>
+              <a:t>gone permanently. The disk archive is the system of record.</a:t>
+            </a:r>
+          </a:p>
+          <a:p/>
+          <a:p>
+            <a:r>
+              <a:t>Aatish will now show this running on one vehicle.</a:t>
+            </a:r>
+          </a:p>
+          <a:p/>
+          <a:p>
+            <a:r>
+              <a:t>--------------------------------------------------------------</a:t>
+            </a:r>
+          </a:p>
+          <a:p>
+            <a:r>
+              <a:t>DELIVERY: Trace the diagram left to right once. Do not read every box. Clear handover.</a:t>
             </a:r>
           </a:p>
         </p:txBody>
@@ -1002,7 +1441,76 @@
           <a:lstStyle/>
           <a:p>
             <a:r>
-              <a:t>[45s]  AATISH. Rubric asks for one concrete example — this is it. The first-vs-last point is the memorable bit, and it justifies the partition key decision from Borna's contract slide.</a:t>
+              <a:t>[45s  |  AATISH  |  ~122 words @ 163 wpm]</a:t>
+            </a:r>
+          </a:p>
+          <a:p>
+            <a:r>
+              <a:t>==============================================================</a:t>
+            </a:r>
+          </a:p>
+          <a:p/>
+          <a:p>
+            <a:r>
+              <a:t>This is one real vehicle -- bus 5885, on a Muni trip. Across four consecutive</a:t>
+            </a:r>
+          </a:p>
+          <a:p>
+            <a:r>
+              <a:t>polls you can watch it approach stop 46, report STOPPED_AT stop 47, still be</a:t>
+            </a:r>
+          </a:p>
+          <a:p>
+            <a:r>
+              <a:t>stopped there, and then move on.</a:t>
+            </a:r>
+          </a:p>
+          <a:p/>
+          <a:p>
+            <a:r>
+              <a:t>The arrival is the FIRST stopped sighting. A parked bus reports that status on</a:t>
+            </a:r>
+          </a:p>
+          <a:p>
+            <a:r>
+              <a:t>every poll while it waits, so if you took the last one you would be measuring</a:t>
+            </a:r>
+          </a:p>
+          <a:p>
+            <a:r>
+              <a:t>departure, not arrival -- and nothing would ever tell you.</a:t>
+            </a:r>
+          </a:p>
+          <a:p/>
+          <a:p>
+            <a:r>
+              <a:t>Which means the resolver has to remember what it saw before. It holds per-trip</a:t>
+            </a:r>
+          </a:p>
+          <a:p>
+            <a:r>
+              <a:t>state. And that is exactly why the partition key Borna described matters: if</a:t>
+            </a:r>
+          </a:p>
+          <a:p>
+            <a:r>
+              <a:t>those four observations arrived out of order, we would record the arrival at the</a:t>
+            </a:r>
+          </a:p>
+          <a:p>
+            <a:r>
+              <a:t>wrong moment, or miss it entirely.</a:t>
+            </a:r>
+          </a:p>
+          <a:p/>
+          <a:p>
+            <a:r>
+              <a:t>--------------------------------------------------------------</a:t>
+            </a:r>
+          </a:p>
+          <a:p>
+            <a:r>
+              <a:t>DELIVERY: This closes the loop on the key decision from slide 3. Make that link explicit.</a:t>
             </a:r>
           </a:p>
         </p:txBody>
@@ -1072,7 +1580,86 @@
           <a:lstStyle/>
           <a:p>
             <a:r>
-              <a:t>[48s]  AATISH. Read one row, not five: 'at twenty minutes out, only 23% land within a minute.' Then the independence point — that is what makes the number mean anything.</a:t>
+              <a:t>[48s  |  AATISH  |  ~127 words @ 159 wpm]</a:t>
+            </a:r>
+          </a:p>
+          <a:p>
+            <a:r>
+              <a:t>==============================================================</a:t>
+            </a:r>
+          </a:p>
+          <a:p/>
+          <a:p>
+            <a:r>
+              <a:t>Here is the answer. Under two minutes out, Muni's predictions are excellent --</a:t>
+            </a:r>
+          </a:p>
+          <a:p>
+            <a:r>
+              <a:t>median error thirteen seconds, ninety-three percent within a minute. But accuracy</a:t>
+            </a:r>
+          </a:p>
+          <a:p>
+            <a:r>
+              <a:t>falls off steadily with horizon. At twenty minutes out, only twenty-three percent</a:t>
+            </a:r>
+          </a:p>
+          <a:p>
+            <a:r>
+              <a:t>land within a minute.</a:t>
+            </a:r>
+          </a:p>
+          <a:p/>
+          <a:p>
+            <a:r>
+              <a:t>The bias column is the one that matters. It is negative at every horizon and it</a:t>
+            </a:r>
+          </a:p>
+          <a:p>
+            <a:r>
+              <a:t>grows. Negative means the agency predicts EARLIER than we observe -- buses arrive</a:t>
+            </a:r>
+          </a:p>
+          <a:p>
+            <a:r>
+              <a:t>later than promised.</a:t>
+            </a:r>
+          </a:p>
+          <a:p/>
+          <a:p>
+            <a:r>
+              <a:t>This number only means something because the two halves are independent. The</a:t>
+            </a:r>
+          </a:p>
+          <a:p>
+            <a:r>
+              <a:t>prediction comes from TripUpdates; the actual comes from GPS positions. Had we</a:t>
+            </a:r>
+          </a:p>
+          <a:p>
+            <a:r>
+              <a:t>derived arrivals from the predictions themselves -- which is a documented,</a:t>
+            </a:r>
+          </a:p>
+          <a:p>
+            <a:r>
+              <a:t>tempting technique -- we would be measuring the agency against itself and getting</a:t>
+            </a:r>
+          </a:p>
+          <a:p>
+            <a:r>
+              <a:t>a beautiful number that means absolutely nothing.</a:t>
+            </a:r>
+          </a:p>
+          <a:p/>
+          <a:p>
+            <a:r>
+              <a:t>--------------------------------------------------------------</a:t>
+            </a:r>
+          </a:p>
+          <a:p>
+            <a:r>
+              <a:t>DELIVERY: Read ONE row aloud, not five. The independence point is the real content.</a:t>
             </a:r>
           </a:p>
         </p:txBody>
@@ -1142,7 +1729,76 @@
           <a:lstStyle/>
           <a:p>
             <a:r>
-              <a:t>[42s]  AATISH. Rubric: one evidence-based lesson. This is the strongest story in the project — we deleted a feature that improved our score. Land the bold line and pause.</a:t>
+              <a:t>[42s  |  AATISH  |  ~111 words @ 159 wpm]</a:t>
+            </a:r>
+          </a:p>
+          <a:p>
+            <a:r>
+              <a:t>==============================================================</a:t>
+            </a:r>
+          </a:p>
+          <a:p/>
+          <a:p>
+            <a:r>
+              <a:t>Our best lesson came from a feature we deleted.</a:t>
+            </a:r>
+          </a:p>
+          <a:p/>
+          <a:p>
+            <a:r>
+              <a:t>Day-of-week improved our test error by ten seconds. We removed it anyway --</a:t>
+            </a:r>
+          </a:p>
+          <a:p>
+            <a:r>
+              <a:t>because Monday appeared only in our test window. Thirty-one percent of test rows</a:t>
+            </a:r>
+          </a:p>
+          <a:p>
+            <a:r>
+              <a:t>carried a value the model had never seen in training, so they silently fell into</a:t>
+            </a:r>
+          </a:p>
+          <a:p>
+            <a:r>
+              <a:t>an adjacent day's correction, purely through where the bin boundaries happened to</a:t>
+            </a:r>
+          </a:p>
+          <a:p>
+            <a:r>
+              <a:t>land. The gain was an artifact of binning, not learned structure.</a:t>
+            </a:r>
+          </a:p>
+          <a:p/>
+          <a:p>
+            <a:r>
+              <a:t>Every real bug we hit had that same shape. A mislabelled partition column. A</a:t>
+            </a:r>
+          </a:p>
+          <a:p>
+            <a:r>
+              <a:t>duplicate replay that doubled our sample size while leaving every average</a:t>
+            </a:r>
+          </a:p>
+          <a:p>
+            <a:r>
+              <a:t>identical. None of them crashed. Several produced better-looking numbers than the</a:t>
+            </a:r>
+          </a:p>
+          <a:p>
+            <a:r>
+              <a:t>correct version.</a:t>
+            </a:r>
+          </a:p>
+          <a:p/>
+          <a:p>
+            <a:r>
+              <a:t>--------------------------------------------------------------</a:t>
+            </a:r>
+          </a:p>
+          <a:p>
+            <a:r>
+              <a:t>DELIVERY: Pause after 'we removed it anyway'. Let the oddity register before explaining.</a:t>
             </a:r>
           </a:p>
         </p:txBody>
@@ -1212,7 +1868,76 @@
           <a:lstStyle/>
           <a:p>
             <a:r>
-              <a:t>[42s]  AATISH. Rubric: one limitation + one next step. Be honest about the upper bound — examiners reward that. The next step is deliberately small and credible: one email.</a:t>
+              <a:t>[42s  |  AATISH  |  ~113 words @ 161 wpm]</a:t>
+            </a:r>
+          </a:p>
+          <a:p>
+            <a:r>
+              <a:t>==============================================================</a:t>
+            </a:r>
+          </a:p>
+          <a:p/>
+          <a:p>
+            <a:r>
+              <a:t>Our main limitation is coverage. We capture only about twenty-one percent of</a:t>
+            </a:r>
+          </a:p>
+          <a:p>
+            <a:r>
+              <a:t>stop events, because buses dwell at a stop for seconds while we sample every two</a:t>
+            </a:r>
+          </a:p>
+          <a:p>
+            <a:r>
+              <a:t>minutes.</a:t>
+            </a:r>
+          </a:p>
+          <a:p/>
+          <a:p>
+            <a:r>
+              <a:t>And it is not random. The chance of catching a stop scales with how long the bus</a:t>
+            </a:r>
+          </a:p>
+          <a:p>
+            <a:r>
+              <a:t>sits there -- so terminals and layovers are over-represented, and our derived</a:t>
+            </a:r>
+          </a:p>
+          <a:p>
+            <a:r>
+              <a:t>arrivals are systematically biased late. Which means the optimism we measured is</a:t>
+            </a:r>
+          </a:p>
+          <a:p>
+            <a:r>
+              <a:t>an upper bound, not a point estimate.</a:t>
+            </a:r>
+          </a:p>
+          <a:p/>
+          <a:p>
+            <a:r>
+              <a:t>So the next step is deliberately small: email 511 and request a rate limit</a:t>
+            </a:r>
+          </a:p>
+          <a:p>
+            <a:r>
+              <a:t>increase. That one change attacks all three problems at once -- more events</a:t>
+            </a:r>
+          </a:p>
+          <a:p>
+            <a:r>
+              <a:t>captured, tighter timestamps, and less selection bias toward long dwells.</a:t>
+            </a:r>
+          </a:p>
+          <a:p/>
+          <a:p>
+            <a:r>
+              <a:t>--------------------------------------------------------------</a:t>
+            </a:r>
+          </a:p>
+          <a:p>
+            <a:r>
+              <a:t>DELIVERY: Being honest about the upper bound is worth marks. Do not soften it.</a:t>
             </a:r>
           </a:p>
         </p:txBody>

</xml_diff>